<commit_message>
feat: enhance PowerPoint generation by normalizing length handling to inches for improved layout consistency and clarity in formula rendering
</commit_message>
<xml_diff>
--- a/web-presentation/pdf-exports/Week1-Session2-Regression-Models.pptx
+++ b/web-presentation/pdf-exports/Week1-Session2-Regression-Models.pptx
@@ -5436,7 +5436,7 @@
         </p:blipFill>
         <p:spPr>
           <a:xfrm>
-            <a:off x="836131430573" y="2608717363200"/>
+            <a:off x="4984973" y="2852928"/>
             <a:ext cx="2100132" cy="868680"/>
           </a:xfrm>
           <a:prstGeom prst="rect">
@@ -6289,7 +6289,7 @@
         </p:blipFill>
         <p:spPr>
           <a:xfrm>
-            <a:off x="752516614164" y="3566160"/>
+            <a:off x="2813123" y="3566160"/>
             <a:ext cx="1323190" cy="594360"/>
           </a:xfrm>
           <a:prstGeom prst="rect">
@@ -6305,7 +6305,7 @@
         </p:nvSpPr>
         <p:spPr>
           <a:xfrm>
-            <a:off x="822960" y="4206240"/>
+            <a:off x="822959" y="4206240"/>
             <a:ext cx="5303520" cy="274320"/>
           </a:xfrm>
           <a:prstGeom prst="rect">
@@ -7138,7 +7138,7 @@
         </p:blipFill>
         <p:spPr>
           <a:xfrm>
-            <a:off x="752516167836" y="3566160"/>
+            <a:off x="2366795" y="3566160"/>
             <a:ext cx="2215846" cy="868680"/>
           </a:xfrm>
           <a:prstGeom prst="rect">
@@ -7154,7 +7154,7 @@
         </p:nvSpPr>
         <p:spPr>
           <a:xfrm>
-            <a:off x="822960" y="4480559"/>
+            <a:off x="822959" y="4480559"/>
             <a:ext cx="5303520" cy="274320"/>
           </a:xfrm>
           <a:prstGeom prst="rect">
@@ -8655,7 +8655,7 @@
         </p:blipFill>
         <p:spPr>
           <a:xfrm>
-            <a:off x="836131257107" y="2608717363200"/>
+            <a:off x="4811507" y="2852928"/>
             <a:ext cx="2447065" cy="868680"/>
           </a:xfrm>
           <a:prstGeom prst="rect">
@@ -9360,7 +9360,7 @@
         </p:blipFill>
         <p:spPr>
           <a:xfrm>
-            <a:off x="836131298270" y="2608717363200"/>
+            <a:off x="4852669" y="2852928"/>
             <a:ext cx="2364740" cy="868680"/>
           </a:xfrm>
           <a:prstGeom prst="rect">
@@ -13350,7 +13350,7 @@
         </p:blipFill>
         <p:spPr>
           <a:xfrm>
-            <a:off x="836130764919" y="2608717363200"/>
+            <a:off x="4319319" y="2852928"/>
             <a:ext cx="3431440" cy="868680"/>
           </a:xfrm>
           <a:prstGeom prst="rect">
@@ -23735,7 +23735,7 @@
         </p:blipFill>
         <p:spPr>
           <a:xfrm>
-            <a:off x="752515255585" y="3566160"/>
+            <a:off x="1454544" y="3566160"/>
             <a:ext cx="4040348" cy="594360"/>
           </a:xfrm>
           <a:prstGeom prst="rect">
@@ -23751,7 +23751,7 @@
         </p:nvSpPr>
         <p:spPr>
           <a:xfrm>
-            <a:off x="822960" y="4206240"/>
+            <a:off x="822959" y="4206240"/>
             <a:ext cx="5303520" cy="274320"/>
           </a:xfrm>
           <a:prstGeom prst="rect">
@@ -25215,7 +25215,7 @@
         </p:blipFill>
         <p:spPr>
           <a:xfrm>
-            <a:off x="836130018110" y="2608717363200"/>
+            <a:off x="3572509" y="2852928"/>
             <a:ext cx="4925060" cy="640080"/>
           </a:xfrm>
           <a:prstGeom prst="rect">
@@ -27349,7 +27349,7 @@
         </p:blipFill>
         <p:spPr>
           <a:xfrm>
-            <a:off x="836130061566" y="2608717363200"/>
+            <a:off x="3615966" y="2852928"/>
             <a:ext cx="4838146" cy="640080"/>
           </a:xfrm>
           <a:prstGeom prst="rect">
@@ -34747,7 +34747,7 @@
         </p:blipFill>
         <p:spPr>
           <a:xfrm>
-            <a:off x="836130895135" y="2608717363200"/>
+            <a:off x="4449535" y="2852928"/>
             <a:ext cx="3171008" cy="640080"/>
           </a:xfrm>
           <a:prstGeom prst="rect">
@@ -36207,7 +36207,7 @@
         </p:blipFill>
         <p:spPr>
           <a:xfrm>
-            <a:off x="752515337335" y="3566160"/>
+            <a:off x="1536294" y="3566160"/>
             <a:ext cx="3876848" cy="594360"/>
           </a:xfrm>
           <a:prstGeom prst="rect">
@@ -36223,7 +36223,7 @@
         </p:nvSpPr>
         <p:spPr>
           <a:xfrm>
-            <a:off x="822960" y="4206240"/>
+            <a:off x="822959" y="4206240"/>
             <a:ext cx="5303520" cy="274320"/>
           </a:xfrm>
           <a:prstGeom prst="rect">
@@ -37019,7 +37019,7 @@
         </p:blipFill>
         <p:spPr>
           <a:xfrm>
-            <a:off x="752516151997" y="3566160"/>
+            <a:off x="2350956" y="3566160"/>
             <a:ext cx="2247525" cy="594360"/>
           </a:xfrm>
           <a:prstGeom prst="rect">
@@ -37035,7 +37035,7 @@
         </p:nvSpPr>
         <p:spPr>
           <a:xfrm>
-            <a:off x="822960" y="4206240"/>
+            <a:off x="822959" y="4206240"/>
             <a:ext cx="5303520" cy="274320"/>
           </a:xfrm>
           <a:prstGeom prst="rect">
@@ -42808,7 +42808,7 @@
         </p:blipFill>
         <p:spPr>
           <a:xfrm>
-            <a:off x="836130699846" y="2608717363200"/>
+            <a:off x="4254246" y="2852928"/>
             <a:ext cx="3561587" cy="868680"/>
           </a:xfrm>
           <a:prstGeom prst="rect">
@@ -43513,7 +43513,7 @@
         </p:blipFill>
         <p:spPr>
           <a:xfrm>
-            <a:off x="836127853042" y="2608717363200"/>
+            <a:off x="1407442" y="2852928"/>
             <a:ext cx="9255195" cy="868679"/>
           </a:xfrm>
           <a:prstGeom prst="rect">
@@ -44218,7 +44218,7 @@
         </p:blipFill>
         <p:spPr>
           <a:xfrm>
-            <a:off x="836131134030" y="2608717363200"/>
+            <a:off x="4688430" y="2852928"/>
             <a:ext cx="2693219" cy="868680"/>
           </a:xfrm>
           <a:prstGeom prst="rect">
@@ -44923,7 +44923,7 @@
         </p:blipFill>
         <p:spPr>
           <a:xfrm>
-            <a:off x="836131313643" y="2608717363200"/>
+            <a:off x="4868043" y="2852928"/>
             <a:ext cx="2333993" cy="640080"/>
           </a:xfrm>
           <a:prstGeom prst="rect">
@@ -47946,7 +47946,7 @@
         </p:blipFill>
         <p:spPr>
           <a:xfrm>
-            <a:off x="752515962219" y="3566160"/>
+            <a:off x="2161178" y="3566160"/>
             <a:ext cx="2627080" cy="868680"/>
           </a:xfrm>
           <a:prstGeom prst="rect">
@@ -47962,7 +47962,7 @@
         </p:nvSpPr>
         <p:spPr>
           <a:xfrm>
-            <a:off x="822960" y="4480559"/>
+            <a:off x="822959" y="4480559"/>
             <a:ext cx="5303520" cy="274320"/>
           </a:xfrm>
           <a:prstGeom prst="rect">
@@ -51269,7 +51269,7 @@
         </p:blipFill>
         <p:spPr>
           <a:xfrm>
-            <a:off x="752515418338" y="3566160"/>
+            <a:off x="1617297" y="3566160"/>
             <a:ext cx="3714842" cy="868680"/>
           </a:xfrm>
           <a:prstGeom prst="rect">
@@ -51285,7 +51285,7 @@
         </p:nvSpPr>
         <p:spPr>
           <a:xfrm>
-            <a:off x="822960" y="4480559"/>
+            <a:off x="822959" y="4480559"/>
             <a:ext cx="5303520" cy="274320"/>
           </a:xfrm>
           <a:prstGeom prst="rect">
@@ -52081,7 +52081,7 @@
         </p:blipFill>
         <p:spPr>
           <a:xfrm>
-            <a:off x="836130943586" y="2608717363200"/>
+            <a:off x="4497986" y="2852928"/>
             <a:ext cx="3074106" cy="640080"/>
           </a:xfrm>
           <a:prstGeom prst="rect">
@@ -54207,7 +54207,7 @@
         </p:blipFill>
         <p:spPr>
           <a:xfrm>
-            <a:off x="836131276494" y="2608717363200"/>
+            <a:off x="4830894" y="2852928"/>
             <a:ext cx="2408291" cy="868680"/>
           </a:xfrm>
           <a:prstGeom prst="rect">
@@ -54912,7 +54912,7 @@
         </p:blipFill>
         <p:spPr>
           <a:xfrm>
-            <a:off x="836130679718" y="2608717363200"/>
+            <a:off x="4234118" y="2852928"/>
             <a:ext cx="3601843" cy="868680"/>
           </a:xfrm>
           <a:prstGeom prst="rect">
@@ -55617,7 +55617,7 @@
         </p:blipFill>
         <p:spPr>
           <a:xfrm>
-            <a:off x="836130630280" y="2608717363200"/>
+            <a:off x="4184680" y="2852928"/>
             <a:ext cx="3700718" cy="868680"/>
           </a:xfrm>
           <a:prstGeom prst="rect">
@@ -56322,7 +56322,7 @@
         </p:blipFill>
         <p:spPr>
           <a:xfrm>
-            <a:off x="836129980728" y="2608717363200"/>
+            <a:off x="3535128" y="2852928"/>
             <a:ext cx="4999823" cy="868680"/>
           </a:xfrm>
           <a:prstGeom prst="rect">
@@ -61686,7 +61686,7 @@
         </p:blipFill>
         <p:spPr>
           <a:xfrm>
-            <a:off x="836129802714" y="2608717363200"/>
+            <a:off x="3357114" y="2852928"/>
             <a:ext cx="5355850" cy="640080"/>
           </a:xfrm>
           <a:prstGeom prst="rect">
@@ -62428,7 +62428,7 @@
         </p:blipFill>
         <p:spPr>
           <a:xfrm>
-            <a:off x="836130415409" y="2608717363200"/>
+            <a:off x="3969809" y="2852928"/>
             <a:ext cx="4130460" cy="640080"/>
           </a:xfrm>
           <a:prstGeom prst="rect">

</xml_diff>